<commit_message>
Add Retention Console, advanced analytics and CI
- Dash Retention Console: overview, member drill-down, live scenario simulator, insights
- GRU sequence challenger (PyTorch) with paired-bootstrap comparison
- Survival analysis, behavioural personas, profit-optimal threshold, A/B test sizing
- Next-quarter (Jul-Sep 2024) watchlist, PSI drift and fairness monitoring
- Model card, GitHub Actions CI, report/deck/README updates
</commit_message>
<xml_diff>
--- a/presentation/churn_presentation.pptx
+++ b/presentation/churn_presentation.pptx
@@ -723,7 +723,7 @@
           <a:lstStyle/>
           <a:p>
             <a:r>
-              <a:t>To close, six actions for the next 90 days. Split the churn KPI so management sees what retention can actually influence, and add a 60-day no-purchase trigger. Run the scoring and next-best-action list every month. Treat support as a retention lever and close the loop inside the two-month window. Use free nudges before paid offers. Revisit tier perks, since Platinum isn't buying loyalty. And prove the uplift with a hold-out control group before scaling, because the economics rest on assumptions until we measure them. Everything I've shown regenerates from one command, and the feature pipeline is already ported to Spark for Databricks. Thank you; happy to take questions.</a:t>
+              <a:t>To close, six actions for the next 90 days. Split the churn KPI so management sees what retention can actually influence, and add a 60-day no-purchase trigger. Run the scoring and next-best-action list every month. Treat support as a retention lever and close the loop inside the two-month window. Use free nudges before paid offers. Revisit tier perks, since Platinum isn't buying loyalty. And prove the uplift with a hold-out control group before scaling, because the economics rest on assumptions until we measure them; about 730 flagged members are enough to detect a 15% uplift. Everything I've shown regenerates from one command, the feature pipeline is ported to Spark for Databricks, and there is a Dash retention console where the CRM team can explore members and test their own assumptions. Thank you; happy to take questions.</a:t>
             </a:r>
           </a:p>
         </p:txBody>
@@ -1213,7 +1213,7 @@
           <a:lstStyle/>
           <a:p>
             <a:r>
-              <a:t>On active members, the recency rule reaches a PR-AUC of 0.46. All three machine-learning models roughly double it, to around 0.8, on a quarter they never saw. Logistic regression won on validation; gradient boosting scores a touch higher on test, but the confidence intervals overlap almost completely, so I deploy the simpler, transparent model and keep boosting as a challenger. At the tuned threshold we flag 179 active members and three out of four real churners are among them. The calibration plot, bottom right, shows the probabilities can be trusted as real odds.</a:t>
+              <a:t>On active members, the recency rule reaches a PR-AUC of 0.46. All three machine-learning models roughly double it, to around 0.8, on a quarter they never saw. Logistic regression won on validation; gradient boosting scores a touch higher on test, but the confidence intervals overlap almost completely, so I deploy the simpler, transparent model and keep boosting as a challenger. At the tuned threshold we flag 179 active members and three out of four real churners are among them. The calibration plot, bottom right, shows the probabilities can be trusted as real odds. I also trained a GRU network on the raw monthly sequences: it scores slightly higher and wins in 97% of bootstrap resamples, so the plan is to shadow-score it for a quarter and promote it if the gain holds: champion and challenger.</a:t>
             </a:r>
           </a:p>
         </p:txBody>
@@ -4564,7 +4564,7 @@
                 </a:solidFill>
                 <a:latin typeface="Calibri"/>
               </a:rPr>
-              <a:t>FreshBasket loyalty churn  ·  10</a:t>
+              <a:t>Silent Cart  ·  FreshBasket loyalty churn  ·  10</a:t>
             </a:r>
           </a:p>
         </p:txBody>
@@ -5792,7 +5792,7 @@
                 </a:solidFill>
                 <a:latin typeface="Calibri"/>
               </a:rPr>
-              <a:t>FreshBasket loyalty churn  ·  11</a:t>
+              <a:t>Silent Cart  ·  FreshBasket loyalty churn  ·  11</a:t>
             </a:r>
           </a:p>
         </p:txBody>
@@ -7301,7 +7301,7 @@
                 </a:solidFill>
                 <a:latin typeface="Calibri"/>
               </a:rPr>
-              <a:t>20% hold-out control for one quarter; replace assumed uplifts with measured ones</a:t>
+              <a:t>20% hold-out: ~729 flagged members detect a 15% uplift; replace assumptions with measurements</a:t>
             </a:r>
           </a:p>
         </p:txBody>
@@ -7345,7 +7345,7 @@
                 </a:solidFill>
                 <a:latin typeface="Calibri"/>
               </a:rPr>
-              <a:t>Azure Data Factory → Delta (Databricks) → PySpark features → MLflow champion model → CRM action queue / FastAPI scoring  ·  monitor PR-AUC, calibration &amp; drift monthly</a:t>
+              <a:t>Azure Data Factory → Delta (Databricks) → PySpark features → MLflow champion model → CRM queue + Dash Retention Console (Databricks Apps)  ·  monitor PR-AUC, calibration &amp; PSI drift monthly</a:t>
             </a:r>
           </a:p>
         </p:txBody>
@@ -7476,7 +7476,7 @@
                 </a:solidFill>
                 <a:latin typeface="Calibri"/>
               </a:rPr>
-              <a:t>FreshBasket loyalty churn  ·  2</a:t>
+              <a:t>Silent Cart  ·  FreshBasket loyalty churn  ·  2</a:t>
             </a:r>
           </a:p>
         </p:txBody>
@@ -8277,7 +8277,7 @@
                 </a:solidFill>
                 <a:latin typeface="Calibri"/>
               </a:rPr>
-              <a:t>FreshBasket loyalty churn  ·  3</a:t>
+              <a:t>Silent Cart  ·  FreshBasket loyalty churn  ·  3</a:t>
             </a:r>
           </a:p>
         </p:txBody>
@@ -9208,7 +9208,7 @@
                 </a:solidFill>
                 <a:latin typeface="Calibri"/>
               </a:rPr>
-              <a:t>FreshBasket loyalty churn  ·  4</a:t>
+              <a:t>Silent Cart  ·  FreshBasket loyalty churn  ·  4</a:t>
             </a:r>
           </a:p>
         </p:txBody>
@@ -9595,7 +9595,7 @@
                 </a:solidFill>
                 <a:latin typeface="Calibri"/>
               </a:rPr>
-              <a:t>FreshBasket loyalty churn  ·  5</a:t>
+              <a:t>Silent Cart  ·  FreshBasket loyalty churn  ·  5</a:t>
             </a:r>
           </a:p>
         </p:txBody>
@@ -10098,7 +10098,7 @@
                 </a:solidFill>
                 <a:latin typeface="Calibri"/>
               </a:rPr>
-              <a:t>FreshBasket loyalty churn  ·  6</a:t>
+              <a:t>Silent Cart  ·  FreshBasket loyalty churn  ·  6</a:t>
             </a:r>
           </a:p>
         </p:txBody>
@@ -10436,7 +10436,7 @@
                 </a:solidFill>
                 <a:latin typeface="Calibri"/>
               </a:rPr>
-              <a:t>FreshBasket loyalty churn  ·  7</a:t>
+              <a:t>Silent Cart  ·  FreshBasket loyalty churn  ·  7</a:t>
             </a:r>
           </a:p>
         </p:txBody>
@@ -11682,7 +11682,7 @@
                 </a:solidFill>
                 <a:latin typeface="Calibri"/>
               </a:rPr>
-              <a:t>FreshBasket loyalty churn  ·  8</a:t>
+              <a:t>Silent Cart  ·  FreshBasket loyalty churn  ·  8</a:t>
             </a:r>
           </a:p>
         </p:txBody>
@@ -12493,7 +12493,7 @@
                 </a:solidFill>
                 <a:latin typeface="Calibri"/>
               </a:rPr>
-              <a:t>Logistic regression (best on validation). Gradient boosting is statistically tied; it stays as challenger and SHAP cross-check</a:t>
+              <a:t>Logistic regression (best of the tabular models on validation). A GRU sequence model (PyTorch) scores 0.82, likely better: shadow-test it next quarter</a:t>
             </a:r>
           </a:p>
           <a:p>
@@ -12716,7 +12716,7 @@
                 </a:solidFill>
                 <a:latin typeface="Calibri"/>
               </a:rPr>
-              <a:t>FreshBasket loyalty churn  ·  9</a:t>
+              <a:t>Silent Cart  ·  FreshBasket loyalty churn  ·  9</a:t>
             </a:r>
           </a:p>
         </p:txBody>

</xml_diff>

<commit_message>
Close audit loose ends; add presenter name
- Title slide: Guru Prasaath D
- README: Python 3.12+ (numpy/scipy/shap requirement)
- Hypothesis tests exclude imputed ages, so pipeline and notebook agree; outputs now
  byte-identical across re-runs (MLflow summary no longer stores run IDs/timestamps)
- Report: updated pipeline overview sentence
- API /score returns top-3 SHAP drivers and next best action
- Dashboard honours PORT; Medium-risk cut-off defined once in config
- Removed unused imports/variables; ruff lint step added to CI
</commit_message>
<xml_diff>
--- a/presentation/churn_presentation.pptx
+++ b/presentation/churn_presentation.pptx
@@ -4411,8 +4411,8 @@
         </p:nvSpPr>
         <p:spPr>
           <a:xfrm>
-            <a:off x="731520" y="5943600"/>
-            <a:ext cx="7315200" cy="365760"/>
+            <a:off x="731520" y="5852160"/>
+            <a:ext cx="10058400" cy="457200"/>
           </a:xfrm>
           <a:prstGeom prst="rect">
             <a:avLst/>
@@ -4427,13 +4427,22 @@
           <a:p>
             <a:pPr algn="l"/>
             <a:r>
+              <a:rPr sz="1500" b="1" i="0">
+                <a:solidFill>
+                  <a:srgbClr val="FFFFFF"/>
+                </a:solidFill>
+                <a:latin typeface="Calibri"/>
+              </a:rPr>
+              <a:t>Guru Prasaath D</a:t>
+            </a:r>
+            <a:r>
               <a:rPr sz="1200" b="0" i="0">
                 <a:solidFill>
                   <a:srgbClr val="BFE3CF"/>
                 </a:solidFill>
                 <a:latin typeface="Calibri"/>
               </a:rPr>
-              <a:t>Data Science  ·  Tailwyndz Propel Internship assessment</a:t>
+              <a:t>   ·   Data Science  ·  Tailwyndz Propel Internship assessment</a:t>
             </a:r>
           </a:p>
         </p:txBody>

</xml_diff>

<commit_message>
Speaker notes: spoken-friendly amounts, 'on average' wording, optional live-demo cue
</commit_message>
<xml_diff>
--- a/presentation/churn_presentation.pptx
+++ b/presentation/churn_presentation.pptx
@@ -653,7 +653,7 @@
           <a:lstStyle/>
           <a:p>
             <a:r>
-              <a:t>Now the money. Assumptions are explicit: a ten-dollar coupon cuts a member's churn probability by 15%, a fifteen-dollar service call by 25%, and a member's value is six months of their spend at a 25% margin. The blanket coupon, today's approach, costs about $24k on this cohort and loses money, because most recipients were staying anyway or are already gone. The playbook gives each member at most one action and only when it pays back: about 43 churners prevented for $3.9k, a +$3.6k return. The brief's support-outreach idea works, but only when targeted: calling everyone with tickets loses money, while calling the model-flagged ones makes money. The sensitivity chart shows targeted actions break even at roughly half the assumed effect.</a:t>
+              <a:t>Now the money. Assumptions are explicit: a ten-dollar coupon cuts a member's churn probability by 15%, a fifteen-dollar service call by 25%, and a member's value is six months of their spend at a 25% margin. The blanket coupon, today's approach, costs about $24k on this cohort and loses money, because most recipients were staying anyway or are already gone. The playbook gives each member at most one action and only when it pays back: about 43 churners prevented for $3.9k, a $3.6k return. The brief's support-outreach idea works, but only when targeted: calling everyone with tickets loses money, while calling the model-flagged ones makes money. The sensitivity chart shows targeted actions break even at roughly half the assumed effect.</a:t>
             </a:r>
           </a:p>
         </p:txBody>
@@ -723,7 +723,7 @@
           <a:lstStyle/>
           <a:p>
             <a:r>
-              <a:t>To close, six actions for the next 90 days. Split the churn KPI so management sees what retention can actually influence, and add a 60-day no-purchase trigger. Run the scoring and next-best-action list every month. Treat support as a retention lever and close the loop inside the two-month window. Use free nudges before paid offers. Revisit tier perks, since Platinum isn't buying loyalty. And prove the uplift with a hold-out control group before scaling, because the economics rest on assumptions until we measure them; about 730 flagged members are enough to detect a 15% uplift. Everything I've shown regenerates from one command, the feature pipeline is ported to Spark for Databricks, and there is a Dash retention console where the CRM team can explore members and test their own assumptions. Thank you; happy to take questions.</a:t>
+              <a:t>To close, six actions for the next 90 days. Split the churn KPI so management sees what retention can actually influence, and add a 60-day no-purchase trigger. Run the scoring and next-best-action list every month. Treat support as a retention lever and close the loop inside the two-month window. Use free nudges before paid offers. Revisit tier perks, since Platinum isn't buying loyalty. And prove the uplift with a hold-out control group before scaling, because the economics rest on assumptions until we measure them; about 730 flagged members are enough to detect a 15% uplift. Everything I've shown regenerates from one command, the feature pipeline is ported to Spark for Databricks, and there is a Dash retention console where the CRM team can explore members and test their own assumptions. [Optional, if time allows: switch to the live console for about 60 seconds. Open a high-risk member, click Draft with AI, then drag one simulator slider.] Thank you; happy to take questions.</a:t>
             </a:r>
           </a:p>
         </p:txBody>
@@ -793,7 +793,7 @@
           <a:lstStyle/>
           <a:p>
             <a:r>
-              <a:t>Here's the whole story on one slide. First, 80% of members labelled as churned had already gone quiet for three months or more before the label window started; that is win-back, not prediction. Second, among members still shopping, the model catches 76% of the ones who leave, with 70% precision, against a base rate under 10%. Third, support experience is a strong lever: members with three or more tickets churn at nearly ten times the rate of members with none. And fourth, targeting changes the economics: the playbook returns about +$3.6k on this cohort where the blanket coupon loses $15.4k. My recommendation is at the bottom; I'll come back to it at the end.</a:t>
+              <a:t>Here's the whole story on one slide. First, 80% of members labelled as churned had already gone quiet for three months or more before the label window started; that is win-back, not prediction. Second, among members still shopping, the model catches 76% of the ones who leave, with 70% precision, against a base rate under 10%. Third, support experience is a strong lever: members with three or more tickets churn at nearly ten times the rate of members with none. And fourth, targeting changes the economics: the playbook returns about $3.6k on this cohort where the blanket coupon loses $15.4k. My recommendation is at the bottom; I'll come back to it at the end.</a:t>
             </a:r>
           </a:p>
         </p:txBody>
@@ -1003,7 +1003,7 @@
           <a:lstStyle/>
           <a:p>
             <a:r>
-              <a:t>Here I lined up every active member on their last purchase before April and looked backwards. Retained members, in blue, are flat. Churners, in orange, show the same sequence every time: transactions, app sessions and email opens fade over roughly two months, while support tickets spike. That gives us a concrete intervention window, and simple triggers a CRM team can use without any model: a 40% drop in spend, app use falling below one session every two months, or a formal complaint. All of these are statistically significant after correcting for multiple tests.</a:t>
+              <a:t>Here I lined up every active member on their last purchase before April and looked backwards. Retained members, in blue, are flat. Churners, in orange, show the same sequence on average: transactions, app sessions and email opens fade over roughly two months, while support tickets spike. That gives us a concrete intervention window, and simple triggers a CRM team can use without any model: a 40% drop in spend, app use falling below one session every two months, or a formal complaint. All of these are statistically significant after correcting for multiple tests.</a:t>
             </a:r>
           </a:p>
         </p:txBody>

</xml_diff>

<commit_message>
Rewrite speaker notes in plain English (main point / say / point at / next)
- Same structure in the PowerPoint notes pane and presentation/speaker_notes.md
- Short sentences, one idea per line, numbers still filled from pipeline results
- Corrected break-even wording: targeting breaks even at ~60% of the assumed effect
</commit_message>
<xml_diff>
--- a/presentation/churn_presentation.pptx
+++ b/presentation/churn_presentation.pptx
@@ -513,7 +513,57 @@
           <a:lstStyle/>
           <a:p>
             <a:r>
-              <a:t>Good morning. FreshBasket asked a simple question: which loyalty members are about to stop shopping, and what should we do about it? Today they send the same offers to everyone. In the next 12 minutes I'll show four things: that the churn number management sees mixes two very different problems; the warning signs that appear about two months before a member leaves; a model that catches about three in four at-risk members on a quarter it never saw; and a targeted retention playbook that turns today's loss-making blanket coupon into a positive return.</a:t>
+              <a:t>MAIN POINT: Most of the "churn" has already happened. I will show how to stop the rest.</a:t>
+            </a:r>
+          </a:p>
+          <a:p>
+            <a:r>
+              <a:t>SAY:</a:t>
+            </a:r>
+          </a:p>
+          <a:p>
+            <a:r>
+              <a:t>- Good morning. I am Guru Prasaath.</a:t>
+            </a:r>
+          </a:p>
+          <a:p>
+            <a:r>
+              <a:t>- FreshBasket asked two questions: which loyalty members will stop shopping, and what should we do about it?</a:t>
+            </a:r>
+          </a:p>
+          <a:p>
+            <a:r>
+              <a:t>- Today they send the same offer to everyone. That wastes money.</a:t>
+            </a:r>
+          </a:p>
+          <a:p>
+            <a:r>
+              <a:t>- In the next 12 minutes I will show four things:</a:t>
+            </a:r>
+          </a:p>
+          <a:p>
+            <a:r>
+              <a:t>1. The churn number hides two very different problems.</a:t>
+            </a:r>
+          </a:p>
+          <a:p>
+            <a:r>
+              <a:t>2. Members show warning signs about 2 months before they leave.</a:t>
+            </a:r>
+          </a:p>
+          <a:p>
+            <a:r>
+              <a:t>3. A model that catches 3 out of 4 leavers, on data it never saw.</a:t>
+            </a:r>
+          </a:p>
+          <a:p>
+            <a:r>
+              <a:t>4. A targeted plan that makes money instead of losing it.</a:t>
+            </a:r>
+          </a:p>
+          <a:p>
+            <a:r>
+              <a:t>NEXT: Let me start with the answer.</a:t>
             </a:r>
           </a:p>
         </p:txBody>
@@ -583,7 +633,47 @@
           <a:lstStyle/>
           <a:p>
             <a:r>
-              <a:t>The brief asked whether behavioural, engagement and support features beat demographics alone. The ablation says clearly yes. With only demographics and tier, the model is at the base rate: no better than chance. Adding purchase behaviour jumps it to 0.66, engagement adds another 0.11, and support pushes it to about 0.8. Even with recency removed the model stays near 0.8, so it is reading genuine early-warning signs. By segment, Austin and Columbus run highest and members who joined in 2024 lowest, but these gaps are small next to behaviour, so segments decide which team acts, not who gets targeted.</a:t>
+              <a:t>MAIN POINT: Behaviour predicts churn. Age, city and tier alone do not.</a:t>
+            </a:r>
+          </a:p>
+          <a:p>
+            <a:r>
+              <a:t>SAY:</a:t>
+            </a:r>
+          </a:p>
+          <a:p>
+            <a:r>
+              <a:t>- I added the data groups one at a time (the bars on the right).</a:t>
+            </a:r>
+          </a:p>
+          <a:p>
+            <a:r>
+              <a:t>- Demographics only: 0.11. That is no better than guessing.</a:t>
+            </a:r>
+          </a:p>
+          <a:p>
+            <a:r>
+              <a:t>- Add purchase behaviour: 0.66. Add engagement: 0.77. Add support: 0.80.</a:t>
+            </a:r>
+          </a:p>
+          <a:p>
+            <a:r>
+              <a:t>- Even without "months since last purchase", the model still scores about 0.8. So it finds real early warning signs.</a:t>
+            </a:r>
+          </a:p>
+          <a:p>
+            <a:r>
+              <a:t>- Left chart, by city and tier: the differences are small. Austin and Columbus are the highest; members who joined in 2024 are the lowest.</a:t>
+            </a:r>
+          </a:p>
+          <a:p>
+            <a:r>
+              <a:t>- So use segments to decide WHO acts (which store team), not WHO to target.</a:t>
+            </a:r>
+          </a:p>
+          <a:p>
+            <a:r>
+              <a:t>NEXT: Now the most important part for the business: the money.</a:t>
             </a:r>
           </a:p>
         </p:txBody>
@@ -653,7 +743,47 @@
           <a:lstStyle/>
           <a:p>
             <a:r>
-              <a:t>Now the money. Assumptions are explicit: a ten-dollar coupon cuts a member's churn probability by 15%, a fifteen-dollar service call by 25%, and a member's value is six months of their spend at a 25% margin. The blanket coupon, today's approach, costs about $24k on this cohort and loses money, because most recipients were staying anyway or are already gone. The playbook gives each member at most one action and only when it pays back: about 43 churners prevented for $3.9k, a $3.6k return. The brief's support-outreach idea works, but only when targeted: calling everyone with tickets loses money, while calling the model-flagged ones makes money. The sensitivity chart shows targeted actions break even at roughly half the assumed effect.</a:t>
+              <a:t>MAIN POINT: Targeting turns retention from a loss into a profit.</a:t>
+            </a:r>
+          </a:p>
+          <a:p>
+            <a:r>
+              <a:t>SAY:</a:t>
+            </a:r>
+          </a:p>
+          <a:p>
+            <a:r>
+              <a:t>- My assumptions, stated clearly: a $10 coupon lowers a member's churn risk by 15%. A $15 service call lowers it by 25%. A member's value is 6 months of their spending, at a 25% margin.</a:t>
+            </a:r>
+          </a:p>
+          <a:p>
+            <a:r>
+              <a:t>- Today's coupon for everyone costs about $24k and loses $15.4k. Most people were staying anyway, or had already left.</a:t>
+            </a:r>
+          </a:p>
+          <a:p>
+            <a:r>
+              <a:t>- My plan gives each member at most one action, and only when it pays back. About 43 members are kept, for $3.9k. That is a $3.6k profit.</a:t>
+            </a:r>
+          </a:p>
+          <a:p>
+            <a:r>
+              <a:t>- Calling everyone with support tickets loses money. Calling only the members the model flags makes money.</a:t>
+            </a:r>
+          </a:p>
+          <a:p>
+            <a:r>
+              <a:t>- Targeting still breaks even if the offers work only about 60% as well as I assumed. The coupon for everyone never breaks even.</a:t>
+            </a:r>
+          </a:p>
+          <a:p>
+            <a:r>
+              <a:t>POINT AT: the red bar (today's approach), then the green bar (my plan).</a:t>
+            </a:r>
+          </a:p>
+          <a:p>
+            <a:r>
+              <a:t>NEXT: So here is what I recommend.</a:t>
             </a:r>
           </a:p>
         </p:txBody>
@@ -723,7 +853,57 @@
           <a:lstStyle/>
           <a:p>
             <a:r>
-              <a:t>To close, six actions for the next 90 days. Split the churn KPI so management sees what retention can actually influence, and add a 60-day no-purchase trigger. Run the scoring and next-best-action list every month. Treat support as a retention lever and close the loop inside the two-month window. Use free nudges before paid offers. Revisit tier perks, since Platinum isn't buying loyalty. And prove the uplift with a hold-out control group before scaling, because the economics rest on assumptions until we measure them; about 730 flagged members are enough to detect a 15% uplift. Everything I've shown regenerates from one command, the feature pipeline is ported to Spark for Databricks, and there is a Dash retention console where the CRM team can explore members and test their own assumptions. [Optional, if time allows: switch to the live console for about 60 seconds. Open a high-risk member, click Draft with AI, then drag one simulator slider.] Thank you; happy to take questions.</a:t>
+              <a:t>MAIN POINT: Six actions for the next 90 days.</a:t>
+            </a:r>
+          </a:p>
+          <a:p>
+            <a:r>
+              <a:t>SAY:</a:t>
+            </a:r>
+          </a:p>
+          <a:p>
+            <a:r>
+              <a:t>1. Report the two kinds of churn separately, and add an alert after 60 days with no purchase.</a:t>
+            </a:r>
+          </a:p>
+          <a:p>
+            <a:r>
+              <a:t>2. Score every member each month, and give each one the single best action.</a:t>
+            </a:r>
+          </a:p>
+          <a:p>
+            <a:r>
+              <a:t>3. Fix support problems fast, inside the 2-month warning window.</a:t>
+            </a:r>
+          </a:p>
+          <a:p>
+            <a:r>
+              <a:t>4. Try free nudges (app and email) before paid offers.</a:t>
+            </a:r>
+          </a:p>
+          <a:p>
+            <a:r>
+              <a:t>5. Rethink tier perks. Platinum is not buying loyalty.</a:t>
+            </a:r>
+          </a:p>
+          <a:p>
+            <a:r>
+              <a:t>6. Prove it before scaling: keep 20% of flagged members as a control group. About 729 flagged members are enough to measure a 15% effect.</a:t>
+            </a:r>
+          </a:p>
+          <a:p>
+            <a:r>
+              <a:t>- Everything rebuilds with one command, and there is a live dashboard for the CRM team.</a:t>
+            </a:r>
+          </a:p>
+          <a:p>
+            <a:r>
+              <a:t>OPTIONAL (about 60 seconds, only if time allows): open the live dashboard, click a high-risk member, click "Draft with AI", then move one slider in the simulator.</a:t>
+            </a:r>
+          </a:p>
+          <a:p>
+            <a:r>
+              <a:t>- Thank you. I am happy to take questions.</a:t>
             </a:r>
           </a:p>
         </p:txBody>
@@ -793,7 +973,42 @@
           <a:lstStyle/>
           <a:p>
             <a:r>
-              <a:t>Here's the whole story on one slide. First, 80% of members labelled as churned had already gone quiet for three months or more before the label window started; that is win-back, not prediction. Second, among members still shopping, the model catches 76% of the ones who leave, with 70% precision, against a base rate under 10%. Third, support experience is a strong lever: members with three or more tickets churn at nearly ten times the rate of members with none. And fourth, targeting changes the economics: the playbook returns about $3.6k on this cohort where the blanket coupon loses $15.4k. My recommendation is at the bottom; I'll come back to it at the end.</a:t>
+              <a:t>MAIN POINT: Four numbers tell the whole story.</a:t>
+            </a:r>
+          </a:p>
+          <a:p>
+            <a:r>
+              <a:t>SAY:</a:t>
+            </a:r>
+          </a:p>
+          <a:p>
+            <a:r>
+              <a:t>- 80%: most members labelled "churned" had already stopped buying BEFORE April. They need a win-back offer, not a prediction.</a:t>
+            </a:r>
+          </a:p>
+          <a:p>
+            <a:r>
+              <a:t>- 76%: among members who are still shopping, the model finds 76% of the ones who leave. When it flags someone, it is right 70% of the time. Normally only about 1 in 10 leave.</a:t>
+            </a:r>
+          </a:p>
+          <a:p>
+            <a:r>
+              <a:t>- 37%: members with 3 or more support tickets leave at 37%, compared with 4% for members with none. Service problems drive churn.</a:t>
+            </a:r>
+          </a:p>
+          <a:p>
+            <a:r>
+              <a:t>- $3.6k: my targeted plan earns $3.6k. Today's coupon-for-everyone loses $15.4k.</a:t>
+            </a:r>
+          </a:p>
+          <a:p>
+            <a:r>
+              <a:t>POINT AT: the dark box at the bottom. These are my 3 recommendations. I will come back to them at the end.</a:t>
+            </a:r>
+          </a:p>
+          <a:p>
+            <a:r>
+              <a:t>NEXT: First, I checked whether the data could be trusted.</a:t>
             </a:r>
           </a:p>
         </p:txBody>
@@ -863,7 +1078,47 @@
           <a:lstStyle/>
           <a:p>
             <a:r>
-              <a:t>Before any modelling I audited the three tables; all 28 checks are logged in a CSV. Six findings matter. The real header is on row two. There are duplicate rows, including two pairs where the same customer-month appears with positive and negative spend. 55 spend values are corrupted; because spend equals transactions times basket for 99.8% of rows, I could repair them exactly instead of deleting months. Missing months are data loss, not inactivity. The most important finding is on the right: three columns in the label table are computed using April to June, the very period we predict. Using them would quietly inflate performance, so they're excluded, and a unit test enforces that features never see the future.</a:t>
+              <a:t>MAIN POINT: I cleaned the data first, and I found 3 columns that "cheat".</a:t>
+            </a:r>
+          </a:p>
+          <a:p>
+            <a:r>
+              <a:t>SAY:</a:t>
+            </a:r>
+          </a:p>
+          <a:p>
+            <a:r>
+              <a:t>- I ran 28 data checks. Every check is logged in a file.</a:t>
+            </a:r>
+          </a:p>
+          <a:p>
+            <a:r>
+              <a:t>- Problems I fixed: a hidden header row, duplicate rows, 55 broken spend values, impossible zeros and missing months.</a:t>
+            </a:r>
+          </a:p>
+          <a:p>
+            <a:r>
+              <a:t>- Broken spend: "spend = transactions x basket size" is true for 99.8% of rows. So I could rebuild the wrong values exactly, without deleting any data.</a:t>
+            </a:r>
+          </a:p>
+          <a:p>
+            <a:r>
+              <a:t>- Most important: 3 columns in the label table use April-June data. That is the period we are trying to predict. It is like seeing the exam answers. This is called "leakage".</a:t>
+            </a:r>
+          </a:p>
+          <a:p>
+            <a:r>
+              <a:t>- I removed them. With them, the score would look better than it really is: 0.80 would become 0.87. An automatic test makes sure this cannot happen again.</a:t>
+            </a:r>
+          </a:p>
+          <a:p>
+            <a:r>
+              <a:t>POINT AT: the orange dots on the chart. These are the broken spend values.</a:t>
+            </a:r>
+          </a:p>
+          <a:p>
+            <a:r>
+              <a:t>NEXT: Once the data was clean, one chart changed my whole approach.</a:t>
             </a:r>
           </a:p>
         </p:txBody>
@@ -933,7 +1188,52 @@
           <a:lstStyle/>
           <a:p>
             <a:r>
-              <a:t>This chart changed how I framed the whole project. Churn probability is a cliff in recency: a member who bought last month churns at about 3%; miss one month and it's 38%; miss two and it's 81%; beyond that it's essentially 100%. So the official churn rate of 34% mixes 653 members who were already gone with 1,715 active members who churn at under 10%. That matters for management, because the KPI overstates what retention can influence. It matters for data science too: any model looks brilliant on the lapsed group. So from here on I report every result for active members separately.</a:t>
+              <a:t>MAIN POINT: There are two different kinds of churn hidden in one number.</a:t>
+            </a:r>
+          </a:p>
+          <a:p>
+            <a:r>
+              <a:t>SAY:</a:t>
+            </a:r>
+          </a:p>
+          <a:p>
+            <a:r>
+              <a:t>- This chart shows churn by "months since the member's last purchase".</a:t>
+            </a:r>
+          </a:p>
+          <a:p>
+            <a:r>
+              <a:t>- Bought last month: about 3% leave. Missed 1 month: 38%. Missed 2 months: 81%. Missed 3 or more: almost 100%.</a:t>
+            </a:r>
+          </a:p>
+          <a:p>
+            <a:r>
+              <a:t>- So the official churn rate of 34% mixes two groups:</a:t>
+            </a:r>
+          </a:p>
+          <a:p>
+            <a:r>
+              <a:t>- LAPSED: 653 members who were already gone before April. A simple rule finds them.</a:t>
+            </a:r>
+          </a:p>
+          <a:p>
+            <a:r>
+              <a:t>- ACTIVE: 1,715 members still shopping. Only 9.6% of them leave. This is where prediction really matters.</a:t>
+            </a:r>
+          </a:p>
+          <a:p>
+            <a:r>
+              <a:t>- Any model looks brilliant on the lapsed group. So from now on I show results for ACTIVE members separately. That is the honest number.</a:t>
+            </a:r>
+          </a:p>
+          <a:p>
+            <a:r>
+              <a:t>POINT AT: the blue bars (active) and then the orange bars (lapsed).</a:t>
+            </a:r>
+          </a:p>
+          <a:p>
+            <a:r>
+              <a:t>NEXT: So what happens before an active member leaves?</a:t>
             </a:r>
           </a:p>
         </p:txBody>
@@ -1003,7 +1303,67 @@
           <a:lstStyle/>
           <a:p>
             <a:r>
-              <a:t>Here I lined up every active member on their last purchase before April and looked backwards. Retained members, in blue, are flat. Churners, in orange, show the same sequence on average: transactions, app sessions and email opens fade over roughly two months, while support tickets spike. That gives us a concrete intervention window, and simple triggers a CRM team can use without any model: a 40% drop in spend, app use falling below one session every two months, or a formal complaint. All of these are statistically significant after correcting for multiple tests.</a:t>
+              <a:t>MAIN POINT: Leaving has warning signs, about 2 months in advance.</a:t>
+            </a:r>
+          </a:p>
+          <a:p>
+            <a:r>
+              <a:t>SAY:</a:t>
+            </a:r>
+          </a:p>
+          <a:p>
+            <a:r>
+              <a:t>- I lined up every active member on their last purchase, and looked back 6 months.</a:t>
+            </a:r>
+          </a:p>
+          <a:p>
+            <a:r>
+              <a:t>- Blue = members who stayed. Their behaviour is flat.</a:t>
+            </a:r>
+          </a:p>
+          <a:p>
+            <a:r>
+              <a:t>- Orange = members who left. On average they buy less, use the app less and open fewer emails, and their support tickets jump.</a:t>
+            </a:r>
+          </a:p>
+          <a:p>
+            <a:r>
+              <a:t>- This gives the business a 2-month window to act.</a:t>
+            </a:r>
+          </a:p>
+          <a:p>
+            <a:r>
+              <a:t>- Three simple alarms that need no model:</a:t>
+            </a:r>
+          </a:p>
+          <a:p>
+            <a:r>
+              <a:t>- spend drops by 40% or more: 37% of these members leave.</a:t>
+            </a:r>
+          </a:p>
+          <a:p>
+            <a:r>
+              <a:t>- app used less than once every 2 months: 46% leave.</a:t>
+            </a:r>
+          </a:p>
+          <a:p>
+            <a:r>
+              <a:t>- a formal complaint: 17% leave, compared with 9%.</a:t>
+            </a:r>
+          </a:p>
+          <a:p>
+            <a:r>
+              <a:t>- All of these are statistically significant.</a:t>
+            </a:r>
+          </a:p>
+          <a:p>
+            <a:r>
+              <a:t>POINT AT: the "Support tickets" panel. The orange line shoots up at the end.</a:t>
+            </a:r>
+          </a:p>
+          <a:p>
+            <a:r>
+              <a:t>NEXT: Which signals matter most, and does membership tier protect us?</a:t>
             </a:r>
           </a:p>
         </p:txBody>
@@ -1073,7 +1433,47 @@
           <a:lstStyle/>
           <a:p>
             <a:r>
-              <a:t>The brief asked whether tier, marketing engagement or support experience affect churn. The answer is yes, yes, and surprisingly no. Support friction is the clearest operational lever: three or more tickets takes churn from 4% to 37%. Engagement, meaning app sessions and email opens, sits among the top three SHAP drivers in both the logistic and the gradient-boosting model. And membership tier makes no difference: Platinum members leave at the same rate as Silver. The current perks are not buying loyalty, which I'll come back to in the recommendations.</a:t>
+              <a:t>MAIN POINT: Service problems and low engagement matter. Membership tier does not.</a:t>
+            </a:r>
+          </a:p>
+          <a:p>
+            <a:r>
+              <a:t>SAY:</a:t>
+            </a:r>
+          </a:p>
+          <a:p>
+            <a:r>
+              <a:t>- The brief asked about three things: tier, marketing engagement and support experience.</a:t>
+            </a:r>
+          </a:p>
+          <a:p>
+            <a:r>
+              <a:t>- Support: YES. 3 or more tickets means 37% churn, compared with 4%.</a:t>
+            </a:r>
+          </a:p>
+          <a:p>
+            <a:r>
+              <a:t>- Engagement: YES. App use and email opens are among the strongest signals in both models.</a:t>
+            </a:r>
+          </a:p>
+          <a:p>
+            <a:r>
+              <a:t>- Tier: NO. Platinum members leave as often as Silver members (34% vs 35%). The expensive perks are not creating loyalty.</a:t>
+            </a:r>
+          </a:p>
+          <a:p>
+            <a:r>
+              <a:t>- The bar at the bottom shows where the model's signal comes from: mostly behaviour and engagement.</a:t>
+            </a:r>
+          </a:p>
+          <a:p>
+            <a:r>
+              <a:t>POINT AT: the "Tier" bullet on the right.</a:t>
+            </a:r>
+          </a:p>
+          <a:p>
+            <a:r>
+              <a:t>NEXT: Before trusting any model, I tested it the honest way.</a:t>
             </a:r>
           </a:p>
         </p:txBody>
@@ -1143,7 +1543,47 @@
           <a:lstStyle/>
           <a:p>
             <a:r>
-              <a:t>Random splits flatter churn models because the future leaks into training. Instead I replayed the churn definition at earlier cut-offs: July and October 2023 for training, January 2024 for model selection, calibration and the threshold, and the official April to June label only once, at the end. Features only look at the six months before each cut-off. Class imbalance is handled with weights, then the scores are calibrated so a 30% really means 30%; that matters for the money maths. Everything is tracked in MLflow, and the feature pipeline also exists in PySpark, verified identical, so it can run on Databricks.</a:t>
+              <a:t>MAIN POINT: I tested the model the way it will really be used: learn from the past, predict the future.</a:t>
+            </a:r>
+          </a:p>
+          <a:p>
+            <a:r>
+              <a:t>SAY:</a:t>
+            </a:r>
+          </a:p>
+          <a:p>
+            <a:r>
+              <a:t>- A random split mixes past and future data. The results look better than they really are.</a:t>
+            </a:r>
+          </a:p>
+          <a:p>
+            <a:r>
+              <a:t>- Instead I trained on July and October 2023, tuned on January 2024, and tested ONCE on the real April-June 2024 answers.</a:t>
+            </a:r>
+          </a:p>
+          <a:p>
+            <a:r>
+              <a:t>- The model only sees the 6 months before each date. It never sees the future.</a:t>
+            </a:r>
+          </a:p>
+          <a:p>
+            <a:r>
+              <a:t>- The scores are calibrated: "30% risk" really means about 30 in 100 such members leave. This matters for the money calculations later.</a:t>
+            </a:r>
+          </a:p>
+          <a:p>
+            <a:r>
+              <a:t>- Engineering: every model run is tracked in MLflow, and the feature code also runs in Spark for Databricks. I tested that it gives identical results.</a:t>
+            </a:r>
+          </a:p>
+          <a:p>
+            <a:r>
+              <a:t>POINT AT: the three boxes at the bottom. The honest test gives 0.81. The "cheating" columns would have given 0.87.</a:t>
+            </a:r>
+          </a:p>
+          <a:p>
+            <a:r>
+              <a:t>NEXT: So how good is the model?</a:t>
             </a:r>
           </a:p>
         </p:txBody>
@@ -1213,7 +1653,52 @@
           <a:lstStyle/>
           <a:p>
             <a:r>
-              <a:t>On active members, the recency rule reaches a PR-AUC of 0.46. All three machine-learning models roughly double it, to around 0.8, on a quarter they never saw. Logistic regression won on validation; gradient boosting scores a touch higher on test, but the confidence intervals overlap almost completely, so I deploy the simpler, transparent model and keep boosting as a challenger. At the tuned threshold we flag 179 active members and three out of four real churners are among them. The calibration plot, bottom right, shows the probabilities can be trusted as real odds. I also trained a GRU network on the raw monthly sequences: it scores slightly higher and wins in 97% of bootstrap resamples, so the plan is to shadow-score it for a quarter and promote it if the gain holds: champion and challenger.</a:t>
+              <a:t>MAIN POINT: For active members, machine learning is about 2x better than a simple rule.</a:t>
+            </a:r>
+          </a:p>
+          <a:p>
+            <a:r>
+              <a:t>SAY:</a:t>
+            </a:r>
+          </a:p>
+          <a:p>
+            <a:r>
+              <a:t>- A simple rule ("has not bought recently") scores 0.46.</a:t>
+            </a:r>
+          </a:p>
+          <a:p>
+            <a:r>
+              <a:t>- My machine-learning models score about 0.8. (1.0 is perfect. Random guessing would score about 0.10.)</a:t>
+            </a:r>
+          </a:p>
+          <a:p>
+            <a:r>
+              <a:t>- Logistic regression won on the tuning data, so I chose it. It is simple and easy to explain. Gradient boosting is about the same.</a:t>
+            </a:r>
+          </a:p>
+          <a:p>
+            <a:r>
+              <a:t>- At my chosen threshold the model flags 179 members, and it catches 3 out of 4 real leavers.</a:t>
+            </a:r>
+          </a:p>
+          <a:p>
+            <a:r>
+              <a:t>- The calibration chart (bottom right) shows the risk percentages can be trusted.</a:t>
+            </a:r>
+          </a:p>
+          <a:p>
+            <a:r>
+              <a:t>- I also tried a deep-learning model (a GRU). It scores slightly higher (0.82). My plan: run it in the background for one quarter, and switch only if it stays better.</a:t>
+            </a:r>
+          </a:p>
+          <a:p>
+            <a:r>
+              <a:t>POINT AT: the table. The bold row is the model I chose.</a:t>
+            </a:r>
+          </a:p>
+          <a:p>
+            <a:r>
+              <a:t>NEXT: A score alone is not enough. People need to know WHY.</a:t>
             </a:r>
           </a:p>
         </p:txBody>
@@ -1283,7 +1768,47 @@
           <a:lstStyle/>
           <a:p>
             <a:r>
-              <a:t>A score on its own doesn't get used. On the left is the SHAP summary for active members: low recent purchasing, low email and app engagement, and recent support tickets push risk up. On the right is what the store or CRM team actually receives: each member's churn probability plus three plain-English reasons, drawn from that member's own SHAP values and grouped so the three reasons are different. That's the bridge from a model to an action. One caution: SHAP explains the model, not causation; that's why the next step is an experiment, not a guess. And the last mile is automated too: for the priority members an LLM on Groq drafts the actual message or call script from these same three reasons, under guardrails that block invented promo codes, false apologies and any mention of tracking.</a:t>
+              <a:t>MAIN POINT: Every member gets a risk score, three reasons, and a ready-to-send message.</a:t>
+            </a:r>
+          </a:p>
+          <a:p>
+            <a:r>
+              <a:t>SAY:</a:t>
+            </a:r>
+          </a:p>
+          <a:p>
+            <a:r>
+              <a:t>- Left: what pushes risk up for the whole group: low purchases, low app and email use, and recent support tickets.</a:t>
+            </a:r>
+          </a:p>
+          <a:p>
+            <a:r>
+              <a:t>- Right: what the store team sees for EACH member: the risk, plus 3 reasons in plain English.</a:t>
+            </a:r>
+          </a:p>
+          <a:p>
+            <a:r>
+              <a:t>- One honest caution: these reasons explain the model. They do not prove cause. That is why I recommend a test before spending at scale.</a:t>
+            </a:r>
+          </a:p>
+          <a:p>
+            <a:r>
+              <a:t>- The last step is automated too. An AI writes the message or call script from the same 3 reasons.</a:t>
+            </a:r>
+          </a:p>
+          <a:p>
+            <a:r>
+              <a:t>- Safety checks block made-up promo codes, wrong apologies and any mention of tracking. If the AI fails a check, a safe template is used.</a:t>
+            </a:r>
+          </a:p>
+          <a:p>
+            <a:r>
+              <a:t>POINT AT: one member card on the right.</a:t>
+            </a:r>
+          </a:p>
+          <a:p>
+            <a:r>
+              <a:t>NEXT: Do we really need behaviour data, or is basic customer information enough?</a:t>
             </a:r>
           </a:p>
         </p:txBody>

</xml_diff>

<commit_message>
Speaker notes: clean presenter script without stage-direction labels
</commit_message>
<xml_diff>
--- a/presentation/churn_presentation.pptx
+++ b/presentation/churn_presentation.pptx
@@ -513,12 +513,7 @@
           <a:lstStyle/>
           <a:p>
             <a:r>
-              <a:t>MAIN POINT: Most of the "churn" has already happened. I will show how to stop the rest.</a:t>
-            </a:r>
-          </a:p>
-          <a:p>
-            <a:r>
-              <a:t>SAY:</a:t>
+              <a:t>Most of the "churn" has already happened. I will show how to stop the rest.</a:t>
             </a:r>
           </a:p>
           <a:p>
@@ -563,7 +558,7 @@
           </a:p>
           <a:p>
             <a:r>
-              <a:t>NEXT: Let me start with the answer.</a:t>
+              <a:t>Let me start with the answer.</a:t>
             </a:r>
           </a:p>
         </p:txBody>
@@ -633,12 +628,7 @@
           <a:lstStyle/>
           <a:p>
             <a:r>
-              <a:t>MAIN POINT: Behaviour predicts churn. Age, city and tier alone do not.</a:t>
-            </a:r>
-          </a:p>
-          <a:p>
-            <a:r>
-              <a:t>SAY:</a:t>
+              <a:t>Behaviour predicts churn. Age, city and tier alone do not.</a:t>
             </a:r>
           </a:p>
           <a:p>
@@ -673,7 +663,7 @@
           </a:p>
           <a:p>
             <a:r>
-              <a:t>NEXT: Now the most important part for the business: the money.</a:t>
+              <a:t>Now the most important part for the business: the money.</a:t>
             </a:r>
           </a:p>
         </p:txBody>
@@ -743,12 +733,7 @@
           <a:lstStyle/>
           <a:p>
             <a:r>
-              <a:t>MAIN POINT: Targeting turns retention from a loss into a profit.</a:t>
-            </a:r>
-          </a:p>
-          <a:p>
-            <a:r>
-              <a:t>SAY:</a:t>
+              <a:t>Targeting turns retention from a loss into a profit.</a:t>
             </a:r>
           </a:p>
           <a:p>
@@ -778,12 +763,7 @@
           </a:p>
           <a:p>
             <a:r>
-              <a:t>POINT AT: the red bar (today's approach), then the green bar (my plan).</a:t>
-            </a:r>
-          </a:p>
-          <a:p>
-            <a:r>
-              <a:t>NEXT: So here is what I recommend.</a:t>
+              <a:t>So here is what I recommend.</a:t>
             </a:r>
           </a:p>
         </p:txBody>
@@ -853,12 +833,7 @@
           <a:lstStyle/>
           <a:p>
             <a:r>
-              <a:t>MAIN POINT: Six actions for the next 90 days.</a:t>
-            </a:r>
-          </a:p>
-          <a:p>
-            <a:r>
-              <a:t>SAY:</a:t>
+              <a:t>Six actions for the next 90 days.</a:t>
             </a:r>
           </a:p>
           <a:p>
@@ -898,7 +873,7 @@
           </a:p>
           <a:p>
             <a:r>
-              <a:t>OPTIONAL (about 60 seconds, only if time allows): open the live dashboard, click a high-risk member, click "Draft with AI", then move one slider in the simulator.</a:t>
+              <a:t>- If time allows, a one-minute live demo: open a high-risk member in the dashboard, click "Draft with AI", then move one slider in the simulator.</a:t>
             </a:r>
           </a:p>
           <a:p>
@@ -973,12 +948,7 @@
           <a:lstStyle/>
           <a:p>
             <a:r>
-              <a:t>MAIN POINT: Four numbers tell the whole story.</a:t>
-            </a:r>
-          </a:p>
-          <a:p>
-            <a:r>
-              <a:t>SAY:</a:t>
+              <a:t>Four numbers tell the whole story.</a:t>
             </a:r>
           </a:p>
           <a:p>
@@ -1003,12 +973,7 @@
           </a:p>
           <a:p>
             <a:r>
-              <a:t>POINT AT: the dark box at the bottom. These are my 3 recommendations. I will come back to them at the end.</a:t>
-            </a:r>
-          </a:p>
-          <a:p>
-            <a:r>
-              <a:t>NEXT: First, I checked whether the data could be trusted.</a:t>
+              <a:t>First, I checked whether the data could be trusted.</a:t>
             </a:r>
           </a:p>
         </p:txBody>
@@ -1078,12 +1043,7 @@
           <a:lstStyle/>
           <a:p>
             <a:r>
-              <a:t>MAIN POINT: I cleaned the data first, and I found 3 columns that "cheat".</a:t>
-            </a:r>
-          </a:p>
-          <a:p>
-            <a:r>
-              <a:t>SAY:</a:t>
+              <a:t>I cleaned the data first, and I found 3 columns that "cheat".</a:t>
             </a:r>
           </a:p>
           <a:p>
@@ -1113,12 +1073,7 @@
           </a:p>
           <a:p>
             <a:r>
-              <a:t>POINT AT: the orange dots on the chart. These are the broken spend values.</a:t>
-            </a:r>
-          </a:p>
-          <a:p>
-            <a:r>
-              <a:t>NEXT: Once the data was clean, one chart changed my whole approach.</a:t>
+              <a:t>Once the data was clean, one chart changed my whole approach.</a:t>
             </a:r>
           </a:p>
         </p:txBody>
@@ -1188,12 +1143,7 @@
           <a:lstStyle/>
           <a:p>
             <a:r>
-              <a:t>MAIN POINT: There are two different kinds of churn hidden in one number.</a:t>
-            </a:r>
-          </a:p>
-          <a:p>
-            <a:r>
-              <a:t>SAY:</a:t>
+              <a:t>There are two different kinds of churn hidden in one number.</a:t>
             </a:r>
           </a:p>
           <a:p>
@@ -1228,12 +1178,7 @@
           </a:p>
           <a:p>
             <a:r>
-              <a:t>POINT AT: the blue bars (active) and then the orange bars (lapsed).</a:t>
-            </a:r>
-          </a:p>
-          <a:p>
-            <a:r>
-              <a:t>NEXT: So what happens before an active member leaves?</a:t>
+              <a:t>So what happens before an active member leaves?</a:t>
             </a:r>
           </a:p>
         </p:txBody>
@@ -1303,12 +1248,7 @@
           <a:lstStyle/>
           <a:p>
             <a:r>
-              <a:t>MAIN POINT: Leaving has warning signs, about 2 months in advance.</a:t>
-            </a:r>
-          </a:p>
-          <a:p>
-            <a:r>
-              <a:t>SAY:</a:t>
+              <a:t>Leaving has warning signs, about 2 months in advance.</a:t>
             </a:r>
           </a:p>
           <a:p>
@@ -1358,12 +1298,7 @@
           </a:p>
           <a:p>
             <a:r>
-              <a:t>POINT AT: the "Support tickets" panel. The orange line shoots up at the end.</a:t>
-            </a:r>
-          </a:p>
-          <a:p>
-            <a:r>
-              <a:t>NEXT: Which signals matter most, and does membership tier protect us?</a:t>
+              <a:t>Which signals matter most, and does membership tier protect us?</a:t>
             </a:r>
           </a:p>
         </p:txBody>
@@ -1433,12 +1368,7 @@
           <a:lstStyle/>
           <a:p>
             <a:r>
-              <a:t>MAIN POINT: Service problems and low engagement matter. Membership tier does not.</a:t>
-            </a:r>
-          </a:p>
-          <a:p>
-            <a:r>
-              <a:t>SAY:</a:t>
+              <a:t>Service problems and low engagement matter. Membership tier does not.</a:t>
             </a:r>
           </a:p>
           <a:p>
@@ -1468,12 +1398,7 @@
           </a:p>
           <a:p>
             <a:r>
-              <a:t>POINT AT: the "Tier" bullet on the right.</a:t>
-            </a:r>
-          </a:p>
-          <a:p>
-            <a:r>
-              <a:t>NEXT: Before trusting any model, I tested it the honest way.</a:t>
+              <a:t>Before trusting any model, I tested it the honest way.</a:t>
             </a:r>
           </a:p>
         </p:txBody>
@@ -1543,12 +1468,7 @@
           <a:lstStyle/>
           <a:p>
             <a:r>
-              <a:t>MAIN POINT: I tested the model the way it will really be used: learn from the past, predict the future.</a:t>
-            </a:r>
-          </a:p>
-          <a:p>
-            <a:r>
-              <a:t>SAY:</a:t>
+              <a:t>I tested the model the way it will really be used: learn from the past, predict the future.</a:t>
             </a:r>
           </a:p>
           <a:p>
@@ -1578,12 +1498,7 @@
           </a:p>
           <a:p>
             <a:r>
-              <a:t>POINT AT: the three boxes at the bottom. The honest test gives 0.81. The "cheating" columns would have given 0.87.</a:t>
-            </a:r>
-          </a:p>
-          <a:p>
-            <a:r>
-              <a:t>NEXT: So how good is the model?</a:t>
+              <a:t>So how good is the model?</a:t>
             </a:r>
           </a:p>
         </p:txBody>
@@ -1653,12 +1568,7 @@
           <a:lstStyle/>
           <a:p>
             <a:r>
-              <a:t>MAIN POINT: For active members, machine learning is about 2x better than a simple rule.</a:t>
-            </a:r>
-          </a:p>
-          <a:p>
-            <a:r>
-              <a:t>SAY:</a:t>
+              <a:t>For active members, machine learning is about 2x better than a simple rule.</a:t>
             </a:r>
           </a:p>
           <a:p>
@@ -1693,12 +1603,7 @@
           </a:p>
           <a:p>
             <a:r>
-              <a:t>POINT AT: the table. The bold row is the model I chose.</a:t>
-            </a:r>
-          </a:p>
-          <a:p>
-            <a:r>
-              <a:t>NEXT: A score alone is not enough. People need to know WHY.</a:t>
+              <a:t>A score alone is not enough. People need to know WHY.</a:t>
             </a:r>
           </a:p>
         </p:txBody>
@@ -1768,12 +1673,7 @@
           <a:lstStyle/>
           <a:p>
             <a:r>
-              <a:t>MAIN POINT: Every member gets a risk score, three reasons, and a ready-to-send message.</a:t>
-            </a:r>
-          </a:p>
-          <a:p>
-            <a:r>
-              <a:t>SAY:</a:t>
+              <a:t>Every member gets a risk score, three reasons, and a ready-to-send message.</a:t>
             </a:r>
           </a:p>
           <a:p>
@@ -1803,12 +1703,7 @@
           </a:p>
           <a:p>
             <a:r>
-              <a:t>POINT AT: one member card on the right.</a:t>
-            </a:r>
-          </a:p>
-          <a:p>
-            <a:r>
-              <a:t>NEXT: Do we really need behaviour data, or is basic customer information enough?</a:t>
+              <a:t>Do we really need behaviour data, or is basic customer information enough?</a:t>
             </a:r>
           </a:p>
         </p:txBody>

</xml_diff>